<commit_message>
Wire PowerPoint connectors to source/destination shapes
Each arrow now carries stCxn/endCxn OOXML attributes referencing the
shape IDs it connects, so dragging a box in PowerPoint drags the
attached arrows with it. Straight connectors for vertical flow;
elbow connectors for branching paths so PowerPoint can auto-route.

https://claude.ai/code/session_0186zG6Pr9VM5M9H5RAVKgcK
</commit_message>
<xml_diff>
--- a/spirometry_pathway.pptx
+++ b/spirometry_pathway.pptx
@@ -3105,7 +3105,7 @@
           <a:noFill/>
         </p:spPr>
         <p:txBody>
-          <a:bodyPr wrap="square" lIns="18288" rIns="18288" tIns="18288" bIns="18288" anchor="ctr">
+          <a:bodyPr wrap="square" lIns="27432" rIns="27432" tIns="18288" bIns="18288" anchor="ctr">
             <a:spAutoFit/>
           </a:bodyPr>
           <a:lstStyle/>
@@ -3140,7 +3140,7 @@
           <a:noFill/>
         </p:spPr>
         <p:txBody>
-          <a:bodyPr wrap="square" lIns="18288" rIns="18288" tIns="18288" bIns="18288" anchor="ctr">
+          <a:bodyPr wrap="square" lIns="27432" rIns="27432" tIns="18288" bIns="18288" anchor="ctr">
             <a:spAutoFit/>
           </a:bodyPr>
           <a:lstStyle/>
@@ -3197,7 +3197,7 @@
           </a:fontRef>
         </p:style>
         <p:txBody>
-          <a:bodyPr rtlCol="0" anchor="ctr" wrap="square" lIns="54864" rIns="54864" tIns="27432" bIns="27432"/>
+          <a:bodyPr rtlCol="0" anchor="ctr" wrap="square" lIns="64008" rIns="64008" tIns="36576" bIns="36576"/>
           <a:lstStyle/>
           <a:p>
             <a:pPr algn="ctr"/>
@@ -3213,45 +3213,9 @@
           </a:p>
         </p:txBody>
       </p:sp>
-      <p:cxnSp>
-        <p:nvCxnSpPr>
-          <p:cNvPr id="5" name="Connector 4"/>
-          <p:cNvCxnSpPr/>
-          <p:nvPr/>
-        </p:nvCxnSpPr>
-        <p:spPr>
-          <a:xfrm>
-            <a:off x="4572000" y="1325880"/>
-            <a:ext cx="0" cy="228600"/>
-          </a:xfrm>
-          <a:prstGeom prst="line">
-            <a:avLst/>
-          </a:prstGeom>
-          <a:ln w="19050">
-            <a:solidFill>
-              <a:srgbClr val="3A3A3A"/>
-            </a:solidFill>
-            <a:tailEnd type="triangle" w="med" len="med"/>
-          </a:ln>
-        </p:spPr>
-        <p:style>
-          <a:lnRef idx="2">
-            <a:schemeClr val="accent1"/>
-          </a:lnRef>
-          <a:fillRef idx="0">
-            <a:schemeClr val="accent1"/>
-          </a:fillRef>
-          <a:effectRef idx="1">
-            <a:schemeClr val="accent1"/>
-          </a:effectRef>
-          <a:fontRef idx="minor">
-            <a:schemeClr val="tx1"/>
-          </a:fontRef>
-        </p:style>
-      </p:cxnSp>
-      <p:sp>
-        <p:nvSpPr>
-          <p:cNvPr id="6" name="Rounded Rectangle 5"/>
+      <p:sp>
+        <p:nvSpPr>
+          <p:cNvPr id="5" name="Rounded Rectangle 4"/>
           <p:cNvSpPr/>
           <p:nvPr/>
         </p:nvSpPr>
@@ -3288,7 +3252,7 @@
           </a:fontRef>
         </p:style>
         <p:txBody>
-          <a:bodyPr rtlCol="0" anchor="ctr" wrap="square" lIns="54864" rIns="54864" tIns="27432" bIns="27432"/>
+          <a:bodyPr rtlCol="0" anchor="ctr" wrap="square" lIns="64008" rIns="64008" tIns="36576" bIns="36576"/>
           <a:lstStyle/>
           <a:p>
             <a:pPr algn="ctr"/>
@@ -3304,158 +3268,16 @@
           </a:p>
         </p:txBody>
       </p:sp>
-      <p:cxnSp>
-        <p:nvCxnSpPr>
-          <p:cNvPr id="7" name="Connector 6"/>
-          <p:cNvCxnSpPr/>
-          <p:nvPr/>
-        </p:nvCxnSpPr>
-        <p:spPr>
-          <a:xfrm>
-            <a:off x="4572000" y="2011680"/>
-            <a:ext cx="0" cy="228600"/>
-          </a:xfrm>
-          <a:prstGeom prst="line">
-            <a:avLst/>
-          </a:prstGeom>
-          <a:ln w="19050">
-            <a:solidFill>
-              <a:srgbClr val="3A3A3A"/>
-            </a:solidFill>
-          </a:ln>
-        </p:spPr>
-        <p:style>
-          <a:lnRef idx="2">
-            <a:schemeClr val="accent1"/>
-          </a:lnRef>
-          <a:fillRef idx="0">
-            <a:schemeClr val="accent1"/>
-          </a:fillRef>
-          <a:effectRef idx="1">
-            <a:schemeClr val="accent1"/>
-          </a:effectRef>
-          <a:fontRef idx="minor">
-            <a:schemeClr val="tx1"/>
-          </a:fontRef>
-        </p:style>
-      </p:cxnSp>
-      <p:cxnSp>
-        <p:nvCxnSpPr>
-          <p:cNvPr id="8" name="Connector 7"/>
-          <p:cNvCxnSpPr/>
-          <p:nvPr/>
-        </p:nvCxnSpPr>
-        <p:spPr>
-          <a:xfrm>
-            <a:off x="2103120" y="2240280"/>
-            <a:ext cx="4937760" cy="0"/>
-          </a:xfrm>
-          <a:prstGeom prst="line">
-            <a:avLst/>
-          </a:prstGeom>
-          <a:ln w="19050">
-            <a:solidFill>
-              <a:srgbClr val="3A3A3A"/>
-            </a:solidFill>
-          </a:ln>
-        </p:spPr>
-        <p:style>
-          <a:lnRef idx="2">
-            <a:schemeClr val="accent1"/>
-          </a:lnRef>
-          <a:fillRef idx="0">
-            <a:schemeClr val="accent1"/>
-          </a:fillRef>
-          <a:effectRef idx="1">
-            <a:schemeClr val="accent1"/>
-          </a:effectRef>
-          <a:fontRef idx="minor">
-            <a:schemeClr val="tx1"/>
-          </a:fontRef>
-        </p:style>
-      </p:cxnSp>
-      <p:cxnSp>
-        <p:nvCxnSpPr>
-          <p:cNvPr id="9" name="Connector 8"/>
-          <p:cNvCxnSpPr/>
-          <p:nvPr/>
-        </p:nvCxnSpPr>
-        <p:spPr>
-          <a:xfrm>
-            <a:off x="2103120" y="2240280"/>
-            <a:ext cx="0" cy="274320"/>
-          </a:xfrm>
-          <a:prstGeom prst="line">
-            <a:avLst/>
-          </a:prstGeom>
-          <a:ln w="19050">
-            <a:solidFill>
-              <a:srgbClr val="3A3A3A"/>
-            </a:solidFill>
-            <a:tailEnd type="triangle" w="med" len="med"/>
-          </a:ln>
-        </p:spPr>
-        <p:style>
-          <a:lnRef idx="2">
-            <a:schemeClr val="accent1"/>
-          </a:lnRef>
-          <a:fillRef idx="0">
-            <a:schemeClr val="accent1"/>
-          </a:fillRef>
-          <a:effectRef idx="1">
-            <a:schemeClr val="accent1"/>
-          </a:effectRef>
-          <a:fontRef idx="minor">
-            <a:schemeClr val="tx1"/>
-          </a:fontRef>
-        </p:style>
-      </p:cxnSp>
-      <p:cxnSp>
-        <p:nvCxnSpPr>
-          <p:cNvPr id="10" name="Connector 9"/>
-          <p:cNvCxnSpPr/>
-          <p:nvPr/>
-        </p:nvCxnSpPr>
-        <p:spPr>
-          <a:xfrm>
-            <a:off x="7040880" y="2240280"/>
-            <a:ext cx="0" cy="274320"/>
-          </a:xfrm>
-          <a:prstGeom prst="line">
-            <a:avLst/>
-          </a:prstGeom>
-          <a:ln w="19050">
-            <a:solidFill>
-              <a:srgbClr val="3A3A3A"/>
-            </a:solidFill>
-            <a:tailEnd type="triangle" w="med" len="med"/>
-          </a:ln>
-        </p:spPr>
-        <p:style>
-          <a:lnRef idx="2">
-            <a:schemeClr val="accent1"/>
-          </a:lnRef>
-          <a:fillRef idx="0">
-            <a:schemeClr val="accent1"/>
-          </a:fillRef>
-          <a:effectRef idx="1">
-            <a:schemeClr val="accent1"/>
-          </a:effectRef>
-          <a:fontRef idx="minor">
-            <a:schemeClr val="tx1"/>
-          </a:fontRef>
-        </p:style>
-      </p:cxnSp>
-      <p:sp>
-        <p:nvSpPr>
-          <p:cNvPr id="11" name="TextBox 10"/>
+      <p:sp>
+        <p:nvSpPr>
+          <p:cNvPr id="6" name="TextBox 5"/>
           <p:cNvSpPr txBox="1"/>
           <p:nvPr/>
         </p:nvSpPr>
         <p:spPr>
           <a:xfrm>
-            <a:off x="914399" y="2057400"/>
-            <a:ext cx="2377440" cy="201168"/>
+            <a:off x="822959" y="2057400"/>
+            <a:ext cx="2560320" cy="201168"/>
           </a:xfrm>
           <a:prstGeom prst="rect">
             <a:avLst/>
@@ -3463,7 +3285,7 @@
           <a:noFill/>
         </p:spPr>
         <p:txBody>
-          <a:bodyPr wrap="square" lIns="18288" rIns="18288" tIns="18288" bIns="18288" anchor="ctr">
+          <a:bodyPr wrap="square" lIns="27432" rIns="27432" tIns="18288" bIns="18288" anchor="ctr">
             <a:spAutoFit/>
           </a:bodyPr>
           <a:lstStyle/>
@@ -3483,14 +3305,14 @@
       </p:sp>
       <p:sp>
         <p:nvSpPr>
-          <p:cNvPr id="12" name="TextBox 11"/>
+          <p:cNvPr id="7" name="TextBox 6"/>
           <p:cNvSpPr txBox="1"/>
           <p:nvPr/>
         </p:nvSpPr>
         <p:spPr>
           <a:xfrm>
-            <a:off x="5852160" y="2057400"/>
-            <a:ext cx="2377440" cy="201168"/>
+            <a:off x="5760720" y="2057400"/>
+            <a:ext cx="2560320" cy="201168"/>
           </a:xfrm>
           <a:prstGeom prst="rect">
             <a:avLst/>
@@ -3498,7 +3320,7 @@
           <a:noFill/>
         </p:spPr>
         <p:txBody>
-          <a:bodyPr wrap="square" lIns="18288" rIns="18288" tIns="18288" bIns="18288" anchor="ctr">
+          <a:bodyPr wrap="square" lIns="27432" rIns="27432" tIns="18288" bIns="18288" anchor="ctr">
             <a:spAutoFit/>
           </a:bodyPr>
           <a:lstStyle/>
@@ -3518,7 +3340,7 @@
       </p:sp>
       <p:sp>
         <p:nvSpPr>
-          <p:cNvPr id="13" name="Rounded Rectangle 12"/>
+          <p:cNvPr id="8" name="Rounded Rectangle 7"/>
           <p:cNvSpPr/>
           <p:nvPr/>
         </p:nvSpPr>
@@ -3555,7 +3377,7 @@
           </a:fontRef>
         </p:style>
         <p:txBody>
-          <a:bodyPr rtlCol="0" anchor="ctr" wrap="square" lIns="54864" rIns="54864" tIns="27432" bIns="27432"/>
+          <a:bodyPr rtlCol="0" anchor="ctr" wrap="square" lIns="64008" rIns="64008" tIns="36576" bIns="36576"/>
           <a:lstStyle/>
           <a:p>
             <a:pPr algn="ctr"/>
@@ -3566,51 +3388,14 @@
                 </a:solidFill>
                 <a:latin typeface="Calibri"/>
               </a:rPr>
-              <a:t>Bronchodilator
-reversibility testing</a:t>
-            </a:r>
-          </a:p>
-        </p:txBody>
-      </p:sp>
-      <p:cxnSp>
-        <p:nvCxnSpPr>
-          <p:cNvPr id="14" name="Connector 13"/>
-          <p:cNvCxnSpPr/>
-          <p:nvPr/>
-        </p:nvCxnSpPr>
-        <p:spPr>
-          <a:xfrm>
-            <a:off x="2103120" y="3040380"/>
-            <a:ext cx="0" cy="251460"/>
-          </a:xfrm>
-          <a:prstGeom prst="line">
-            <a:avLst/>
-          </a:prstGeom>
-          <a:ln w="19050">
-            <a:solidFill>
-              <a:srgbClr val="3A3A3A"/>
-            </a:solidFill>
-            <a:tailEnd type="triangle" w="med" len="med"/>
-          </a:ln>
-        </p:spPr>
-        <p:style>
-          <a:lnRef idx="2">
-            <a:schemeClr val="accent1"/>
-          </a:lnRef>
-          <a:fillRef idx="0">
-            <a:schemeClr val="accent1"/>
-          </a:fillRef>
-          <a:effectRef idx="1">
-            <a:schemeClr val="accent1"/>
-          </a:effectRef>
-          <a:fontRef idx="minor">
-            <a:schemeClr val="tx1"/>
-          </a:fontRef>
-        </p:style>
-      </p:cxnSp>
-      <p:sp>
-        <p:nvSpPr>
-          <p:cNvPr id="15" name="Diamond 14"/>
+              <a:t>Bronchodilator reversibility testing</a:t>
+            </a:r>
+          </a:p>
+        </p:txBody>
+      </p:sp>
+      <p:sp>
+        <p:nvSpPr>
+          <p:cNvPr id="9" name="Diamond 8"/>
           <p:cNvSpPr/>
           <p:nvPr/>
         </p:nvSpPr>
@@ -3647,7 +3432,7 @@
           </a:fontRef>
         </p:style>
         <p:txBody>
-          <a:bodyPr rtlCol="0" anchor="ctr" wrap="square" lIns="54864" rIns="54864" tIns="27432" bIns="27432"/>
+          <a:bodyPr rtlCol="0" anchor="ctr" wrap="square" lIns="64008" rIns="64008" tIns="36576" bIns="36576"/>
           <a:lstStyle/>
           <a:p>
             <a:pPr algn="ctr"/>
@@ -3663,80 +3448,9 @@
           </a:p>
         </p:txBody>
       </p:sp>
-      <p:cxnSp>
-        <p:nvCxnSpPr>
-          <p:cNvPr id="16" name="Connector 15"/>
-          <p:cNvCxnSpPr/>
-          <p:nvPr/>
-        </p:nvCxnSpPr>
-        <p:spPr>
-          <a:xfrm>
-            <a:off x="1005840" y="3657600"/>
-            <a:ext cx="0" cy="457200"/>
-          </a:xfrm>
-          <a:prstGeom prst="line">
-            <a:avLst/>
-          </a:prstGeom>
-          <a:ln w="19050">
-            <a:solidFill>
-              <a:srgbClr val="3A3A3A"/>
-            </a:solidFill>
-            <a:tailEnd type="triangle" w="med" len="med"/>
-          </a:ln>
-        </p:spPr>
-        <p:style>
-          <a:lnRef idx="2">
-            <a:schemeClr val="accent1"/>
-          </a:lnRef>
-          <a:fillRef idx="0">
-            <a:schemeClr val="accent1"/>
-          </a:fillRef>
-          <a:effectRef idx="1">
-            <a:schemeClr val="accent1"/>
-          </a:effectRef>
-          <a:fontRef idx="minor">
-            <a:schemeClr val="tx1"/>
-          </a:fontRef>
-        </p:style>
-      </p:cxnSp>
-      <p:sp>
-        <p:nvSpPr>
-          <p:cNvPr id="17" name="TextBox 16"/>
-          <p:cNvSpPr txBox="1"/>
-          <p:nvPr/>
-        </p:nvSpPr>
-        <p:spPr>
-          <a:xfrm>
-            <a:off x="640080" y="3602736"/>
-            <a:ext cx="548640" cy="201168"/>
-          </a:xfrm>
-          <a:prstGeom prst="rect">
-            <a:avLst/>
-          </a:prstGeom>
-          <a:noFill/>
-        </p:spPr>
-        <p:txBody>
-          <a:bodyPr wrap="square" lIns="18288" rIns="18288" tIns="18288" bIns="18288" anchor="ctr">
-            <a:spAutoFit/>
-          </a:bodyPr>
-          <a:lstStyle/>
-          <a:p>
-            <a:pPr algn="ctr"/>
-            <a:r>
-              <a:rPr sz="1100" b="1" i="1">
-                <a:solidFill>
-                  <a:srgbClr val="3D8B3D"/>
-                </a:solidFill>
-                <a:latin typeface="Calibri"/>
-              </a:rPr>
-              <a:t>Yes</a:t>
-            </a:r>
-          </a:p>
-        </p:txBody>
-      </p:sp>
-      <p:sp>
-        <p:nvSpPr>
-          <p:cNvPr id="18" name="Rounded Rectangle 17"/>
+      <p:sp>
+        <p:nvSpPr>
+          <p:cNvPr id="10" name="Rounded Rectangle 9"/>
           <p:cNvSpPr/>
           <p:nvPr/>
         </p:nvSpPr>
@@ -3773,7 +3487,7 @@
           </a:fontRef>
         </p:style>
         <p:txBody>
-          <a:bodyPr rtlCol="0" anchor="ctr" wrap="square" lIns="54864" rIns="54864" tIns="27432" bIns="27432"/>
+          <a:bodyPr rtlCol="0" anchor="ctr" wrap="square" lIns="64008" rIns="64008" tIns="36576" bIns="36576"/>
           <a:lstStyle/>
           <a:p>
             <a:pPr algn="ctr"/>
@@ -3784,85 +3498,14 @@
                 </a:solidFill>
                 <a:latin typeface="Calibri"/>
               </a:rPr>
-              <a:t>Treat as
-asthma + EIB</a:t>
-            </a:r>
-          </a:p>
-        </p:txBody>
-      </p:sp>
-      <p:sp>
-        <p:nvSpPr>
-          <p:cNvPr id="19" name="TextBox 18"/>
-          <p:cNvSpPr txBox="1"/>
-          <p:nvPr/>
-        </p:nvSpPr>
-        <p:spPr>
-          <a:xfrm>
-            <a:off x="2103120" y="3968496"/>
-            <a:ext cx="365760" cy="201168"/>
-          </a:xfrm>
-          <a:prstGeom prst="rect">
-            <a:avLst/>
-          </a:prstGeom>
-          <a:noFill/>
-        </p:spPr>
-        <p:txBody>
-          <a:bodyPr wrap="square" lIns="18288" rIns="18288" tIns="18288" bIns="18288" anchor="ctr">
-            <a:spAutoFit/>
-          </a:bodyPr>
-          <a:lstStyle/>
-          <a:p>
-            <a:pPr algn="l"/>
-            <a:r>
-              <a:rPr sz="1100" b="1" i="1">
-                <a:solidFill>
-                  <a:srgbClr val="B0524C"/>
-                </a:solidFill>
-                <a:latin typeface="Calibri"/>
-              </a:rPr>
-              <a:t>No</a:t>
-            </a:r>
-          </a:p>
-        </p:txBody>
-      </p:sp>
-      <p:cxnSp>
-        <p:nvCxnSpPr>
-          <p:cNvPr id="20" name="Connector 19"/>
-          <p:cNvCxnSpPr/>
-          <p:nvPr/>
-        </p:nvCxnSpPr>
-        <p:spPr>
-          <a:xfrm>
-            <a:off x="2103120" y="4023360"/>
-            <a:ext cx="0" cy="1325880"/>
-          </a:xfrm>
-          <a:prstGeom prst="line">
-            <a:avLst/>
-          </a:prstGeom>
-          <a:ln w="19050">
-            <a:solidFill>
-              <a:srgbClr val="3A3A3A"/>
-            </a:solidFill>
-          </a:ln>
-        </p:spPr>
-        <p:style>
-          <a:lnRef idx="2">
-            <a:schemeClr val="accent1"/>
-          </a:lnRef>
-          <a:fillRef idx="0">
-            <a:schemeClr val="accent1"/>
-          </a:fillRef>
-          <a:effectRef idx="1">
-            <a:schemeClr val="accent1"/>
-          </a:effectRef>
-          <a:fontRef idx="minor">
-            <a:schemeClr val="tx1"/>
-          </a:fontRef>
-        </p:style>
-      </p:cxnSp>
-      <p:sp>
-        <p:nvSpPr>
-          <p:cNvPr id="21" name="Rounded Rectangle 20"/>
+              <a:t>Treat as asthma + EIB</a:t>
+            </a:r>
+          </a:p>
+        </p:txBody>
+      </p:sp>
+      <p:sp>
+        <p:nvSpPr>
+          <p:cNvPr id="11" name="Rounded Rectangle 10"/>
           <p:cNvSpPr/>
           <p:nvPr/>
         </p:nvSpPr>
@@ -3899,7 +3542,7 @@
           </a:fontRef>
         </p:style>
         <p:txBody>
-          <a:bodyPr rtlCol="0" anchor="ctr" wrap="square" lIns="54864" rIns="54864" tIns="27432" bIns="27432"/>
+          <a:bodyPr rtlCol="0" anchor="ctr" wrap="square" lIns="64008" rIns="64008" tIns="36576" bIns="36576"/>
           <a:lstStyle/>
           <a:p>
             <a:pPr algn="ctr"/>
@@ -3910,51 +3553,14 @@
                 </a:solidFill>
                 <a:latin typeface="Calibri"/>
               </a:rPr>
-              <a:t>Empiric pre-exercise SABA
-(15–30 min before exercise)</a:t>
-            </a:r>
-          </a:p>
-        </p:txBody>
-      </p:sp>
-      <p:cxnSp>
-        <p:nvCxnSpPr>
-          <p:cNvPr id="22" name="Connector 21"/>
-          <p:cNvCxnSpPr/>
-          <p:nvPr/>
-        </p:nvCxnSpPr>
-        <p:spPr>
-          <a:xfrm>
-            <a:off x="7040880" y="3040380"/>
-            <a:ext cx="0" cy="251460"/>
-          </a:xfrm>
-          <a:prstGeom prst="line">
-            <a:avLst/>
-          </a:prstGeom>
-          <a:ln w="19050">
-            <a:solidFill>
-              <a:srgbClr val="3A3A3A"/>
-            </a:solidFill>
-            <a:tailEnd type="triangle" w="med" len="med"/>
-          </a:ln>
-        </p:spPr>
-        <p:style>
-          <a:lnRef idx="2">
-            <a:schemeClr val="accent1"/>
-          </a:lnRef>
-          <a:fillRef idx="0">
-            <a:schemeClr val="accent1"/>
-          </a:fillRef>
-          <a:effectRef idx="1">
-            <a:schemeClr val="accent1"/>
-          </a:effectRef>
-          <a:fontRef idx="minor">
-            <a:schemeClr val="tx1"/>
-          </a:fontRef>
-        </p:style>
-      </p:cxnSp>
-      <p:sp>
-        <p:nvSpPr>
-          <p:cNvPr id="23" name="Diamond 22"/>
+              <a:t>Empiric pre-exercise SABA (15–30 min before exercise)</a:t>
+            </a:r>
+          </a:p>
+        </p:txBody>
+      </p:sp>
+      <p:sp>
+        <p:nvSpPr>
+          <p:cNvPr id="12" name="Diamond 11"/>
           <p:cNvSpPr/>
           <p:nvPr/>
         </p:nvSpPr>
@@ -3991,7 +3597,7 @@
           </a:fontRef>
         </p:style>
         <p:txBody>
-          <a:bodyPr rtlCol="0" anchor="ctr" wrap="square" lIns="54864" rIns="54864" tIns="27432" bIns="27432"/>
+          <a:bodyPr rtlCol="0" anchor="ctr" wrap="square" lIns="64008" rIns="64008" tIns="36576" bIns="36576"/>
           <a:lstStyle/>
           <a:p>
             <a:pPr algn="ctr"/>
@@ -4008,80 +3614,9 @@
           </a:p>
         </p:txBody>
       </p:sp>
-      <p:cxnSp>
-        <p:nvCxnSpPr>
-          <p:cNvPr id="24" name="Connector 23"/>
-          <p:cNvCxnSpPr/>
-          <p:nvPr/>
-        </p:nvCxnSpPr>
-        <p:spPr>
-          <a:xfrm>
-            <a:off x="8138160" y="3657600"/>
-            <a:ext cx="0" cy="457200"/>
-          </a:xfrm>
-          <a:prstGeom prst="line">
-            <a:avLst/>
-          </a:prstGeom>
-          <a:ln w="19050">
-            <a:solidFill>
-              <a:srgbClr val="3A3A3A"/>
-            </a:solidFill>
-            <a:tailEnd type="triangle" w="med" len="med"/>
-          </a:ln>
-        </p:spPr>
-        <p:style>
-          <a:lnRef idx="2">
-            <a:schemeClr val="accent1"/>
-          </a:lnRef>
-          <a:fillRef idx="0">
-            <a:schemeClr val="accent1"/>
-          </a:fillRef>
-          <a:effectRef idx="1">
-            <a:schemeClr val="accent1"/>
-          </a:effectRef>
-          <a:fontRef idx="minor">
-            <a:schemeClr val="tx1"/>
-          </a:fontRef>
-        </p:style>
-      </p:cxnSp>
-      <p:sp>
-        <p:nvSpPr>
-          <p:cNvPr id="25" name="TextBox 24"/>
-          <p:cNvSpPr txBox="1"/>
-          <p:nvPr/>
-        </p:nvSpPr>
-        <p:spPr>
-          <a:xfrm>
-            <a:off x="7955279" y="3602736"/>
-            <a:ext cx="548640" cy="201168"/>
-          </a:xfrm>
-          <a:prstGeom prst="rect">
-            <a:avLst/>
-          </a:prstGeom>
-          <a:noFill/>
-        </p:spPr>
-        <p:txBody>
-          <a:bodyPr wrap="square" lIns="18288" rIns="18288" tIns="18288" bIns="18288" anchor="ctr">
-            <a:spAutoFit/>
-          </a:bodyPr>
-          <a:lstStyle/>
-          <a:p>
-            <a:pPr algn="ctr"/>
-            <a:r>
-              <a:rPr sz="1100" b="1" i="1">
-                <a:solidFill>
-                  <a:srgbClr val="3D8B3D"/>
-                </a:solidFill>
-                <a:latin typeface="Calibri"/>
-              </a:rPr>
-              <a:t>Yes</a:t>
-            </a:r>
-          </a:p>
-        </p:txBody>
-      </p:sp>
-      <p:sp>
-        <p:nvSpPr>
-          <p:cNvPr id="26" name="Rounded Rectangle 25"/>
+      <p:sp>
+        <p:nvSpPr>
+          <p:cNvPr id="13" name="Rounded Rectangle 12"/>
           <p:cNvSpPr/>
           <p:nvPr/>
         </p:nvSpPr>
@@ -4118,7 +3653,7 @@
           </a:fontRef>
         </p:style>
         <p:txBody>
-          <a:bodyPr rtlCol="0" anchor="ctr" wrap="square" lIns="54864" rIns="54864" tIns="27432" bIns="27432"/>
+          <a:bodyPr rtlCol="0" anchor="ctr" wrap="square" lIns="64008" rIns="64008" tIns="36576" bIns="36576"/>
           <a:lstStyle/>
           <a:p>
             <a:pPr algn="ctr"/>
@@ -4129,156 +3664,14 @@
                 </a:solidFill>
                 <a:latin typeface="Calibri"/>
               </a:rPr>
-              <a:t>Continue
-pre-exercise SABA</a:t>
-            </a:r>
-          </a:p>
-        </p:txBody>
-      </p:sp>
-      <p:sp>
-        <p:nvSpPr>
-          <p:cNvPr id="27" name="TextBox 26"/>
-          <p:cNvSpPr txBox="1"/>
-          <p:nvPr/>
-        </p:nvSpPr>
-        <p:spPr>
-          <a:xfrm>
-            <a:off x="7040880" y="3968496"/>
-            <a:ext cx="365760" cy="201168"/>
-          </a:xfrm>
-          <a:prstGeom prst="rect">
-            <a:avLst/>
-          </a:prstGeom>
-          <a:noFill/>
-        </p:spPr>
-        <p:txBody>
-          <a:bodyPr wrap="square" lIns="18288" rIns="18288" tIns="18288" bIns="18288" anchor="ctr">
-            <a:spAutoFit/>
-          </a:bodyPr>
-          <a:lstStyle/>
-          <a:p>
-            <a:pPr algn="l"/>
-            <a:r>
-              <a:rPr sz="1100" b="1" i="1">
-                <a:solidFill>
-                  <a:srgbClr val="B0524C"/>
-                </a:solidFill>
-                <a:latin typeface="Calibri"/>
-              </a:rPr>
-              <a:t>No</a:t>
-            </a:r>
-          </a:p>
-        </p:txBody>
-      </p:sp>
-      <p:cxnSp>
-        <p:nvCxnSpPr>
-          <p:cNvPr id="28" name="Connector 27"/>
-          <p:cNvCxnSpPr/>
-          <p:nvPr/>
-        </p:nvCxnSpPr>
-        <p:spPr>
-          <a:xfrm>
-            <a:off x="7040880" y="4023360"/>
-            <a:ext cx="0" cy="1325880"/>
-          </a:xfrm>
-          <a:prstGeom prst="line">
-            <a:avLst/>
-          </a:prstGeom>
-          <a:ln w="19050">
-            <a:solidFill>
-              <a:srgbClr val="3A3A3A"/>
-            </a:solidFill>
-          </a:ln>
-        </p:spPr>
-        <p:style>
-          <a:lnRef idx="2">
-            <a:schemeClr val="accent1"/>
-          </a:lnRef>
-          <a:fillRef idx="0">
-            <a:schemeClr val="accent1"/>
-          </a:fillRef>
-          <a:effectRef idx="1">
-            <a:schemeClr val="accent1"/>
-          </a:effectRef>
-          <a:fontRef idx="minor">
-            <a:schemeClr val="tx1"/>
-          </a:fontRef>
-        </p:style>
-      </p:cxnSp>
-      <p:cxnSp>
-        <p:nvCxnSpPr>
-          <p:cNvPr id="29" name="Connector 28"/>
-          <p:cNvCxnSpPr/>
-          <p:nvPr/>
-        </p:nvCxnSpPr>
-        <p:spPr>
-          <a:xfrm>
-            <a:off x="2103120" y="5349240"/>
-            <a:ext cx="4937760" cy="0"/>
-          </a:xfrm>
-          <a:prstGeom prst="line">
-            <a:avLst/>
-          </a:prstGeom>
-          <a:ln w="19050">
-            <a:solidFill>
-              <a:srgbClr val="3A3A3A"/>
-            </a:solidFill>
-          </a:ln>
-        </p:spPr>
-        <p:style>
-          <a:lnRef idx="2">
-            <a:schemeClr val="accent1"/>
-          </a:lnRef>
-          <a:fillRef idx="0">
-            <a:schemeClr val="accent1"/>
-          </a:fillRef>
-          <a:effectRef idx="1">
-            <a:schemeClr val="accent1"/>
-          </a:effectRef>
-          <a:fontRef idx="minor">
-            <a:schemeClr val="tx1"/>
-          </a:fontRef>
-        </p:style>
-      </p:cxnSp>
-      <p:cxnSp>
-        <p:nvCxnSpPr>
-          <p:cNvPr id="30" name="Connector 29"/>
-          <p:cNvCxnSpPr/>
-          <p:nvPr/>
-        </p:nvCxnSpPr>
-        <p:spPr>
-          <a:xfrm>
-            <a:off x="4572000" y="5349240"/>
-            <a:ext cx="0" cy="274320"/>
-          </a:xfrm>
-          <a:prstGeom prst="line">
-            <a:avLst/>
-          </a:prstGeom>
-          <a:ln w="19050">
-            <a:solidFill>
-              <a:srgbClr val="3A3A3A"/>
-            </a:solidFill>
-            <a:tailEnd type="triangle" w="med" len="med"/>
-          </a:ln>
-        </p:spPr>
-        <p:style>
-          <a:lnRef idx="2">
-            <a:schemeClr val="accent1"/>
-          </a:lnRef>
-          <a:fillRef idx="0">
-            <a:schemeClr val="accent1"/>
-          </a:fillRef>
-          <a:effectRef idx="1">
-            <a:schemeClr val="accent1"/>
-          </a:effectRef>
-          <a:fontRef idx="minor">
-            <a:schemeClr val="tx1"/>
-          </a:fontRef>
-        </p:style>
-      </p:cxnSp>
-      <p:sp>
-        <p:nvSpPr>
-          <p:cNvPr id="31" name="Rounded Rectangle 30"/>
+              <a:t>Continue pre-exercise SABA</a:t>
+            </a:r>
+          </a:p>
+        </p:txBody>
+      </p:sp>
+      <p:sp>
+        <p:nvSpPr>
+          <p:cNvPr id="14" name="Rounded Rectangle 13"/>
           <p:cNvSpPr/>
           <p:nvPr/>
         </p:nvSpPr>
@@ -4315,7 +3708,7 @@
           </a:fontRef>
         </p:style>
         <p:txBody>
-          <a:bodyPr rtlCol="0" anchor="ctr" wrap="square" lIns="54864" rIns="54864" tIns="27432" bIns="27432"/>
+          <a:bodyPr rtlCol="0" anchor="ctr" wrap="square" lIns="64008" rIns="64008" tIns="36576" bIns="36576"/>
           <a:lstStyle/>
           <a:p>
             <a:pPr algn="ctr"/>
@@ -4345,9 +3738,6 @@
             <a:pPr algn="ctr"/>
             <a:r>
               <a:rPr sz="400" b="0" i="0">
-                <a:solidFill>
-                  <a:srgbClr val="1A1A1A"/>
-                </a:solidFill>
                 <a:latin typeface="Calibri"/>
               </a:rPr>
               <a:t> </a:t>
@@ -4379,45 +3769,9 @@
           </a:p>
         </p:txBody>
       </p:sp>
-      <p:cxnSp>
-        <p:nvCxnSpPr>
-          <p:cNvPr id="32" name="Connector 31"/>
-          <p:cNvCxnSpPr/>
-          <p:nvPr/>
-        </p:nvCxnSpPr>
-        <p:spPr>
-          <a:xfrm>
-            <a:off x="4572000" y="6720840"/>
-            <a:ext cx="0" cy="274320"/>
-          </a:xfrm>
-          <a:prstGeom prst="line">
-            <a:avLst/>
-          </a:prstGeom>
-          <a:ln w="19050">
-            <a:solidFill>
-              <a:srgbClr val="3A3A3A"/>
-            </a:solidFill>
-            <a:tailEnd type="triangle" w="med" len="med"/>
-          </a:ln>
-        </p:spPr>
-        <p:style>
-          <a:lnRef idx="2">
-            <a:schemeClr val="accent1"/>
-          </a:lnRef>
-          <a:fillRef idx="0">
-            <a:schemeClr val="accent1"/>
-          </a:fillRef>
-          <a:effectRef idx="1">
-            <a:schemeClr val="accent1"/>
-          </a:effectRef>
-          <a:fontRef idx="minor">
-            <a:schemeClr val="tx1"/>
-          </a:fontRef>
-        </p:style>
-      </p:cxnSp>
-      <p:sp>
-        <p:nvSpPr>
-          <p:cNvPr id="33" name="Diamond 32"/>
+      <p:sp>
+        <p:nvSpPr>
+          <p:cNvPr id="15" name="Diamond 14"/>
           <p:cNvSpPr/>
           <p:nvPr/>
         </p:nvSpPr>
@@ -4454,7 +3808,7 @@
           </a:fontRef>
         </p:style>
         <p:txBody>
-          <a:bodyPr rtlCol="0" anchor="ctr" wrap="square" lIns="54864" rIns="54864" tIns="27432" bIns="27432"/>
+          <a:bodyPr rtlCol="0" anchor="ctr" wrap="square" lIns="64008" rIns="64008" tIns="36576" bIns="36576"/>
           <a:lstStyle/>
           <a:p>
             <a:pPr algn="ctr"/>
@@ -4471,79 +3825,9 @@
           </a:p>
         </p:txBody>
       </p:sp>
-      <p:cxnSp>
-        <p:nvCxnSpPr>
-          <p:cNvPr id="34" name="Connector 33"/>
-          <p:cNvCxnSpPr/>
-          <p:nvPr/>
-        </p:nvCxnSpPr>
-        <p:spPr>
-          <a:xfrm>
-            <a:off x="3474720" y="7360920"/>
-            <a:ext cx="0" cy="457200"/>
-          </a:xfrm>
-          <a:prstGeom prst="line">
-            <a:avLst/>
-          </a:prstGeom>
-          <a:ln w="19050">
-            <a:solidFill>
-              <a:srgbClr val="3A3A3A"/>
-            </a:solidFill>
-            <a:tailEnd type="triangle" w="med" len="med"/>
-          </a:ln>
-        </p:spPr>
-        <p:style>
-          <a:lnRef idx="2">
-            <a:schemeClr val="accent1"/>
-          </a:lnRef>
-          <a:fillRef idx="0">
-            <a:schemeClr val="accent1"/>
-          </a:fillRef>
-          <a:effectRef idx="1">
-            <a:schemeClr val="accent1"/>
-          </a:effectRef>
-          <a:fontRef idx="minor">
-            <a:schemeClr val="tx1"/>
-          </a:fontRef>
-        </p:style>
-      </p:cxnSp>
-      <p:sp>
-        <p:nvSpPr>
-          <p:cNvPr id="35" name="TextBox 34"/>
-          <p:cNvSpPr txBox="1"/>
-          <p:nvPr/>
-        </p:nvSpPr>
-        <p:spPr>
-          <a:xfrm>
-            <a:off x="2834640" y="7306055"/>
-            <a:ext cx="640080" cy="201168"/>
-          </a:xfrm>
-          <a:prstGeom prst="rect">
-            <a:avLst/>
-          </a:prstGeom>
-          <a:noFill/>
-        </p:spPr>
-        <p:txBody>
-          <a:bodyPr wrap="square" lIns="18288" rIns="18288" tIns="18288" bIns="18288" anchor="ctr">
-            <a:spAutoFit/>
-          </a:bodyPr>
-          <a:lstStyle/>
-          <a:p>
-            <a:r>
-              <a:rPr sz="1050" b="1" i="1">
-                <a:solidFill>
-                  <a:srgbClr val="3D8B3D"/>
-                </a:solidFill>
-                <a:latin typeface="Calibri"/>
-              </a:rPr>
-              <a:t>Positive</a:t>
-            </a:r>
-          </a:p>
-        </p:txBody>
-      </p:sp>
-      <p:sp>
-        <p:nvSpPr>
-          <p:cNvPr id="36" name="Rounded Rectangle 35"/>
+      <p:sp>
+        <p:nvSpPr>
+          <p:cNvPr id="16" name="Rounded Rectangle 15"/>
           <p:cNvSpPr/>
           <p:nvPr/>
         </p:nvSpPr>
@@ -4580,7 +3864,7 @@
           </a:fontRef>
         </p:style>
         <p:txBody>
-          <a:bodyPr rtlCol="0" anchor="ctr" wrap="square" lIns="54864" rIns="54864" tIns="27432" bIns="27432"/>
+          <a:bodyPr rtlCol="0" anchor="ctr" wrap="square" lIns="64008" rIns="64008" tIns="36576" bIns="36576"/>
           <a:lstStyle/>
           <a:p>
             <a:pPr algn="ctr"/>
@@ -4591,86 +3875,14 @@
                 </a:solidFill>
                 <a:latin typeface="Calibri"/>
               </a:rPr>
-              <a:t>Diagnose &amp;
-treat EIB</a:t>
-            </a:r>
-          </a:p>
-        </p:txBody>
-      </p:sp>
-      <p:cxnSp>
-        <p:nvCxnSpPr>
-          <p:cNvPr id="37" name="Connector 36"/>
-          <p:cNvCxnSpPr/>
-          <p:nvPr/>
-        </p:nvCxnSpPr>
-        <p:spPr>
-          <a:xfrm>
-            <a:off x="5669280" y="7360920"/>
-            <a:ext cx="0" cy="457200"/>
-          </a:xfrm>
-          <a:prstGeom prst="line">
-            <a:avLst/>
-          </a:prstGeom>
-          <a:ln w="19050">
-            <a:solidFill>
-              <a:srgbClr val="3A3A3A"/>
-            </a:solidFill>
-            <a:tailEnd type="triangle" w="med" len="med"/>
-          </a:ln>
-        </p:spPr>
-        <p:style>
-          <a:lnRef idx="2">
-            <a:schemeClr val="accent1"/>
-          </a:lnRef>
-          <a:fillRef idx="0">
-            <a:schemeClr val="accent1"/>
-          </a:fillRef>
-          <a:effectRef idx="1">
-            <a:schemeClr val="accent1"/>
-          </a:effectRef>
-          <a:fontRef idx="minor">
-            <a:schemeClr val="tx1"/>
-          </a:fontRef>
-        </p:style>
-      </p:cxnSp>
-      <p:sp>
-        <p:nvSpPr>
-          <p:cNvPr id="38" name="TextBox 37"/>
-          <p:cNvSpPr txBox="1"/>
-          <p:nvPr/>
-        </p:nvSpPr>
-        <p:spPr>
-          <a:xfrm>
-            <a:off x="5623559" y="7306055"/>
-            <a:ext cx="731520" cy="201168"/>
-          </a:xfrm>
-          <a:prstGeom prst="rect">
-            <a:avLst/>
-          </a:prstGeom>
-          <a:noFill/>
-        </p:spPr>
-        <p:txBody>
-          <a:bodyPr wrap="square" lIns="18288" rIns="18288" tIns="18288" bIns="18288" anchor="ctr">
-            <a:spAutoFit/>
-          </a:bodyPr>
-          <a:lstStyle/>
-          <a:p>
-            <a:pPr algn="l"/>
-            <a:r>
-              <a:rPr sz="1050" b="1" i="1">
-                <a:solidFill>
-                  <a:srgbClr val="B0524C"/>
-                </a:solidFill>
-                <a:latin typeface="Calibri"/>
-              </a:rPr>
-              <a:t>Negative</a:t>
-            </a:r>
-          </a:p>
-        </p:txBody>
-      </p:sp>
-      <p:sp>
-        <p:nvSpPr>
-          <p:cNvPr id="39" name="Rounded Rectangle 38"/>
+              <a:t>Diagnose &amp; treat EIB</a:t>
+            </a:r>
+          </a:p>
+        </p:txBody>
+      </p:sp>
+      <p:sp>
+        <p:nvSpPr>
+          <p:cNvPr id="17" name="Rounded Rectangle 16"/>
           <p:cNvSpPr/>
           <p:nvPr/>
         </p:nvSpPr>
@@ -4707,7 +3919,7 @@
           </a:fontRef>
         </p:style>
         <p:txBody>
-          <a:bodyPr rtlCol="0" anchor="ctr" wrap="square" lIns="54864" rIns="54864" tIns="27432" bIns="27432"/>
+          <a:bodyPr rtlCol="0" anchor="ctr" wrap="square" lIns="64008" rIns="64008" tIns="36576" bIns="36576"/>
           <a:lstStyle/>
           <a:p>
             <a:pPr algn="ctr"/>
@@ -4718,15 +3930,692 @@
                 </a:solidFill>
                 <a:latin typeface="Calibri"/>
               </a:rPr>
-              <a:t>Evaluate for
-alternative diagnoses</a:t>
-            </a:r>
-          </a:p>
-        </p:txBody>
-      </p:sp>
-      <p:sp>
-        <p:nvSpPr>
-          <p:cNvPr id="40" name="Rounded Rectangle 39"/>
+              <a:t>Evaluate for alternative diagnoses</a:t>
+            </a:r>
+          </a:p>
+        </p:txBody>
+      </p:sp>
+      <p:cxnSp>
+        <p:nvCxnSpPr>
+          <p:cNvPr id="18" name="Connector 17"/>
+          <p:cNvCxnSpPr>
+            <a:stCxn id="4" idx="2"/>
+            <a:endCxn id="5" idx="0"/>
+          </p:cNvCxnSpPr>
+          <p:nvPr/>
+        </p:nvCxnSpPr>
+        <p:spPr>
+          <a:xfrm>
+            <a:off x="4572000" y="1325880"/>
+            <a:ext cx="0" cy="228600"/>
+          </a:xfrm>
+          <a:prstGeom prst="line">
+            <a:avLst/>
+          </a:prstGeom>
+          <a:ln w="20320">
+            <a:solidFill>
+              <a:srgbClr val="3A3A3A"/>
+            </a:solidFill>
+            <a:tailEnd type="triangle" w="med" len="med"/>
+          </a:ln>
+        </p:spPr>
+        <p:style>
+          <a:lnRef idx="2">
+            <a:schemeClr val="accent1"/>
+          </a:lnRef>
+          <a:fillRef idx="0">
+            <a:schemeClr val="accent1"/>
+          </a:fillRef>
+          <a:effectRef idx="1">
+            <a:schemeClr val="accent1"/>
+          </a:effectRef>
+          <a:fontRef idx="minor">
+            <a:schemeClr val="tx1"/>
+          </a:fontRef>
+        </p:style>
+      </p:cxnSp>
+      <p:cxnSp>
+        <p:nvCxnSpPr>
+          <p:cNvPr id="19" name="Connector 18"/>
+          <p:cNvCxnSpPr>
+            <a:stCxn id="5" idx="2"/>
+            <a:endCxn id="8" idx="0"/>
+          </p:cNvCxnSpPr>
+          <p:nvPr/>
+        </p:nvCxnSpPr>
+        <p:spPr>
+          <a:xfrm flipH="1">
+            <a:off x="2103119" y="2011680"/>
+            <a:ext cx="2468881" cy="525780"/>
+          </a:xfrm>
+          <a:prstGeom prst="bentConnector3">
+            <a:avLst/>
+          </a:prstGeom>
+          <a:ln w="20320">
+            <a:solidFill>
+              <a:srgbClr val="3A3A3A"/>
+            </a:solidFill>
+            <a:tailEnd type="triangle" w="med" len="med"/>
+          </a:ln>
+        </p:spPr>
+        <p:style>
+          <a:lnRef idx="2">
+            <a:schemeClr val="accent1"/>
+          </a:lnRef>
+          <a:fillRef idx="0">
+            <a:schemeClr val="accent1"/>
+          </a:fillRef>
+          <a:effectRef idx="1">
+            <a:schemeClr val="accent1"/>
+          </a:effectRef>
+          <a:fontRef idx="minor">
+            <a:schemeClr val="tx1"/>
+          </a:fontRef>
+        </p:style>
+      </p:cxnSp>
+      <p:cxnSp>
+        <p:nvCxnSpPr>
+          <p:cNvPr id="20" name="Connector 19"/>
+          <p:cNvCxnSpPr>
+            <a:stCxn id="5" idx="2"/>
+            <a:endCxn id="11" idx="0"/>
+          </p:cNvCxnSpPr>
+          <p:nvPr/>
+        </p:nvCxnSpPr>
+        <p:spPr>
+          <a:xfrm>
+            <a:off x="4572000" y="2011680"/>
+            <a:ext cx="2468880" cy="525780"/>
+          </a:xfrm>
+          <a:prstGeom prst="bentConnector3">
+            <a:avLst/>
+          </a:prstGeom>
+          <a:ln w="20320">
+            <a:solidFill>
+              <a:srgbClr val="3A3A3A"/>
+            </a:solidFill>
+            <a:tailEnd type="triangle" w="med" len="med"/>
+          </a:ln>
+        </p:spPr>
+        <p:style>
+          <a:lnRef idx="2">
+            <a:schemeClr val="accent1"/>
+          </a:lnRef>
+          <a:fillRef idx="0">
+            <a:schemeClr val="accent1"/>
+          </a:fillRef>
+          <a:effectRef idx="1">
+            <a:schemeClr val="accent1"/>
+          </a:effectRef>
+          <a:fontRef idx="minor">
+            <a:schemeClr val="tx1"/>
+          </a:fontRef>
+        </p:style>
+      </p:cxnSp>
+      <p:cxnSp>
+        <p:nvCxnSpPr>
+          <p:cNvPr id="21" name="Connector 20"/>
+          <p:cNvCxnSpPr>
+            <a:stCxn id="8" idx="2"/>
+            <a:endCxn id="9" idx="0"/>
+          </p:cNvCxnSpPr>
+          <p:nvPr/>
+        </p:nvCxnSpPr>
+        <p:spPr>
+          <a:xfrm>
+            <a:off x="2103119" y="3040380"/>
+            <a:ext cx="0" cy="251460"/>
+          </a:xfrm>
+          <a:prstGeom prst="line">
+            <a:avLst/>
+          </a:prstGeom>
+          <a:ln w="20320">
+            <a:solidFill>
+              <a:srgbClr val="3A3A3A"/>
+            </a:solidFill>
+            <a:tailEnd type="triangle" w="med" len="med"/>
+          </a:ln>
+        </p:spPr>
+        <p:style>
+          <a:lnRef idx="2">
+            <a:schemeClr val="accent1"/>
+          </a:lnRef>
+          <a:fillRef idx="0">
+            <a:schemeClr val="accent1"/>
+          </a:fillRef>
+          <a:effectRef idx="1">
+            <a:schemeClr val="accent1"/>
+          </a:effectRef>
+          <a:fontRef idx="minor">
+            <a:schemeClr val="tx1"/>
+          </a:fontRef>
+        </p:style>
+      </p:cxnSp>
+      <p:cxnSp>
+        <p:nvCxnSpPr>
+          <p:cNvPr id="22" name="Connector 21"/>
+          <p:cNvCxnSpPr>
+            <a:stCxn id="9" idx="3"/>
+            <a:endCxn id="10" idx="0"/>
+          </p:cNvCxnSpPr>
+          <p:nvPr/>
+        </p:nvCxnSpPr>
+        <p:spPr>
+          <a:xfrm>
+            <a:off x="1005839" y="3657600"/>
+            <a:ext cx="1" cy="461772"/>
+          </a:xfrm>
+          <a:prstGeom prst="bentConnector3">
+            <a:avLst/>
+          </a:prstGeom>
+          <a:ln w="20320">
+            <a:solidFill>
+              <a:srgbClr val="3A3A3A"/>
+            </a:solidFill>
+            <a:tailEnd type="triangle" w="med" len="med"/>
+          </a:ln>
+        </p:spPr>
+        <p:style>
+          <a:lnRef idx="2">
+            <a:schemeClr val="accent1"/>
+          </a:lnRef>
+          <a:fillRef idx="0">
+            <a:schemeClr val="accent1"/>
+          </a:fillRef>
+          <a:effectRef idx="1">
+            <a:schemeClr val="accent1"/>
+          </a:effectRef>
+          <a:fontRef idx="minor">
+            <a:schemeClr val="tx1"/>
+          </a:fontRef>
+        </p:style>
+      </p:cxnSp>
+      <p:cxnSp>
+        <p:nvCxnSpPr>
+          <p:cNvPr id="23" name="Connector 22"/>
+          <p:cNvCxnSpPr>
+            <a:stCxn id="9" idx="2"/>
+            <a:endCxn id="14" idx="0"/>
+          </p:cNvCxnSpPr>
+          <p:nvPr/>
+        </p:nvCxnSpPr>
+        <p:spPr>
+          <a:xfrm>
+            <a:off x="2103119" y="4023360"/>
+            <a:ext cx="2468881" cy="1600200"/>
+          </a:xfrm>
+          <a:prstGeom prst="bentConnector3">
+            <a:avLst/>
+          </a:prstGeom>
+          <a:ln w="20320">
+            <a:solidFill>
+              <a:srgbClr val="3A3A3A"/>
+            </a:solidFill>
+            <a:tailEnd type="triangle" w="med" len="med"/>
+          </a:ln>
+        </p:spPr>
+        <p:style>
+          <a:lnRef idx="2">
+            <a:schemeClr val="accent1"/>
+          </a:lnRef>
+          <a:fillRef idx="0">
+            <a:schemeClr val="accent1"/>
+          </a:fillRef>
+          <a:effectRef idx="1">
+            <a:schemeClr val="accent1"/>
+          </a:effectRef>
+          <a:fontRef idx="minor">
+            <a:schemeClr val="tx1"/>
+          </a:fontRef>
+        </p:style>
+      </p:cxnSp>
+      <p:cxnSp>
+        <p:nvCxnSpPr>
+          <p:cNvPr id="24" name="Connector 23"/>
+          <p:cNvCxnSpPr>
+            <a:stCxn id="11" idx="2"/>
+            <a:endCxn id="12" idx="0"/>
+          </p:cNvCxnSpPr>
+          <p:nvPr/>
+        </p:nvCxnSpPr>
+        <p:spPr>
+          <a:xfrm>
+            <a:off x="7040880" y="3040380"/>
+            <a:ext cx="0" cy="251460"/>
+          </a:xfrm>
+          <a:prstGeom prst="line">
+            <a:avLst/>
+          </a:prstGeom>
+          <a:ln w="20320">
+            <a:solidFill>
+              <a:srgbClr val="3A3A3A"/>
+            </a:solidFill>
+            <a:tailEnd type="triangle" w="med" len="med"/>
+          </a:ln>
+        </p:spPr>
+        <p:style>
+          <a:lnRef idx="2">
+            <a:schemeClr val="accent1"/>
+          </a:lnRef>
+          <a:fillRef idx="0">
+            <a:schemeClr val="accent1"/>
+          </a:fillRef>
+          <a:effectRef idx="1">
+            <a:schemeClr val="accent1"/>
+          </a:effectRef>
+          <a:fontRef idx="minor">
+            <a:schemeClr val="tx1"/>
+          </a:fontRef>
+        </p:style>
+      </p:cxnSp>
+      <p:cxnSp>
+        <p:nvCxnSpPr>
+          <p:cNvPr id="25" name="Connector 24"/>
+          <p:cNvCxnSpPr>
+            <a:stCxn id="12" idx="1"/>
+            <a:endCxn id="13" idx="0"/>
+          </p:cNvCxnSpPr>
+          <p:nvPr/>
+        </p:nvCxnSpPr>
+        <p:spPr>
+          <a:xfrm>
+            <a:off x="8138160" y="3657600"/>
+            <a:ext cx="0" cy="461772"/>
+          </a:xfrm>
+          <a:prstGeom prst="bentConnector3">
+            <a:avLst/>
+          </a:prstGeom>
+          <a:ln w="20320">
+            <a:solidFill>
+              <a:srgbClr val="3A3A3A"/>
+            </a:solidFill>
+            <a:tailEnd type="triangle" w="med" len="med"/>
+          </a:ln>
+        </p:spPr>
+        <p:style>
+          <a:lnRef idx="2">
+            <a:schemeClr val="accent1"/>
+          </a:lnRef>
+          <a:fillRef idx="0">
+            <a:schemeClr val="accent1"/>
+          </a:fillRef>
+          <a:effectRef idx="1">
+            <a:schemeClr val="accent1"/>
+          </a:effectRef>
+          <a:fontRef idx="minor">
+            <a:schemeClr val="tx1"/>
+          </a:fontRef>
+        </p:style>
+      </p:cxnSp>
+      <p:cxnSp>
+        <p:nvCxnSpPr>
+          <p:cNvPr id="26" name="Connector 25"/>
+          <p:cNvCxnSpPr>
+            <a:stCxn id="12" idx="2"/>
+            <a:endCxn id="14" idx="0"/>
+          </p:cNvCxnSpPr>
+          <p:nvPr/>
+        </p:nvCxnSpPr>
+        <p:spPr>
+          <a:xfrm flipH="1">
+            <a:off x="4572000" y="4023360"/>
+            <a:ext cx="2468880" cy="1600200"/>
+          </a:xfrm>
+          <a:prstGeom prst="bentConnector3">
+            <a:avLst/>
+          </a:prstGeom>
+          <a:ln w="20320">
+            <a:solidFill>
+              <a:srgbClr val="3A3A3A"/>
+            </a:solidFill>
+            <a:tailEnd type="triangle" w="med" len="med"/>
+          </a:ln>
+        </p:spPr>
+        <p:style>
+          <a:lnRef idx="2">
+            <a:schemeClr val="accent1"/>
+          </a:lnRef>
+          <a:fillRef idx="0">
+            <a:schemeClr val="accent1"/>
+          </a:fillRef>
+          <a:effectRef idx="1">
+            <a:schemeClr val="accent1"/>
+          </a:effectRef>
+          <a:fontRef idx="minor">
+            <a:schemeClr val="tx1"/>
+          </a:fontRef>
+        </p:style>
+      </p:cxnSp>
+      <p:cxnSp>
+        <p:nvCxnSpPr>
+          <p:cNvPr id="27" name="Connector 26"/>
+          <p:cNvCxnSpPr>
+            <a:stCxn id="14" idx="2"/>
+            <a:endCxn id="15" idx="0"/>
+          </p:cNvCxnSpPr>
+          <p:nvPr/>
+        </p:nvCxnSpPr>
+        <p:spPr>
+          <a:xfrm>
+            <a:off x="4572000" y="6720840"/>
+            <a:ext cx="0" cy="274320"/>
+          </a:xfrm>
+          <a:prstGeom prst="line">
+            <a:avLst/>
+          </a:prstGeom>
+          <a:ln w="20320">
+            <a:solidFill>
+              <a:srgbClr val="3A3A3A"/>
+            </a:solidFill>
+            <a:tailEnd type="triangle" w="med" len="med"/>
+          </a:ln>
+        </p:spPr>
+        <p:style>
+          <a:lnRef idx="2">
+            <a:schemeClr val="accent1"/>
+          </a:lnRef>
+          <a:fillRef idx="0">
+            <a:schemeClr val="accent1"/>
+          </a:fillRef>
+          <a:effectRef idx="1">
+            <a:schemeClr val="accent1"/>
+          </a:effectRef>
+          <a:fontRef idx="minor">
+            <a:schemeClr val="tx1"/>
+          </a:fontRef>
+        </p:style>
+      </p:cxnSp>
+      <p:cxnSp>
+        <p:nvCxnSpPr>
+          <p:cNvPr id="28" name="Connector 27"/>
+          <p:cNvCxnSpPr>
+            <a:stCxn id="15" idx="3"/>
+            <a:endCxn id="16" idx="0"/>
+          </p:cNvCxnSpPr>
+          <p:nvPr/>
+        </p:nvCxnSpPr>
+        <p:spPr>
+          <a:xfrm>
+            <a:off x="3474720" y="7360920"/>
+            <a:ext cx="0" cy="461772"/>
+          </a:xfrm>
+          <a:prstGeom prst="bentConnector3">
+            <a:avLst/>
+          </a:prstGeom>
+          <a:ln w="20320">
+            <a:solidFill>
+              <a:srgbClr val="3A3A3A"/>
+            </a:solidFill>
+            <a:tailEnd type="triangle" w="med" len="med"/>
+          </a:ln>
+        </p:spPr>
+        <p:style>
+          <a:lnRef idx="2">
+            <a:schemeClr val="accent1"/>
+          </a:lnRef>
+          <a:fillRef idx="0">
+            <a:schemeClr val="accent1"/>
+          </a:fillRef>
+          <a:effectRef idx="1">
+            <a:schemeClr val="accent1"/>
+          </a:effectRef>
+          <a:fontRef idx="minor">
+            <a:schemeClr val="tx1"/>
+          </a:fontRef>
+        </p:style>
+      </p:cxnSp>
+      <p:cxnSp>
+        <p:nvCxnSpPr>
+          <p:cNvPr id="29" name="Connector 28"/>
+          <p:cNvCxnSpPr>
+            <a:stCxn id="15" idx="1"/>
+            <a:endCxn id="17" idx="0"/>
+          </p:cNvCxnSpPr>
+          <p:nvPr/>
+        </p:nvCxnSpPr>
+        <p:spPr>
+          <a:xfrm>
+            <a:off x="5669280" y="7360920"/>
+            <a:ext cx="0" cy="461772"/>
+          </a:xfrm>
+          <a:prstGeom prst="bentConnector3">
+            <a:avLst/>
+          </a:prstGeom>
+          <a:ln w="20320">
+            <a:solidFill>
+              <a:srgbClr val="3A3A3A"/>
+            </a:solidFill>
+            <a:tailEnd type="triangle" w="med" len="med"/>
+          </a:ln>
+        </p:spPr>
+        <p:style>
+          <a:lnRef idx="2">
+            <a:schemeClr val="accent1"/>
+          </a:lnRef>
+          <a:fillRef idx="0">
+            <a:schemeClr val="accent1"/>
+          </a:fillRef>
+          <a:effectRef idx="1">
+            <a:schemeClr val="accent1"/>
+          </a:effectRef>
+          <a:fontRef idx="minor">
+            <a:schemeClr val="tx1"/>
+          </a:fontRef>
+        </p:style>
+      </p:cxnSp>
+      <p:sp>
+        <p:nvSpPr>
+          <p:cNvPr id="30" name="TextBox 29"/>
+          <p:cNvSpPr txBox="1"/>
+          <p:nvPr/>
+        </p:nvSpPr>
+        <p:spPr>
+          <a:xfrm>
+            <a:off x="502920" y="3611879"/>
+            <a:ext cx="640080" cy="201168"/>
+          </a:xfrm>
+          <a:prstGeom prst="rect">
+            <a:avLst/>
+          </a:prstGeom>
+          <a:noFill/>
+        </p:spPr>
+        <p:txBody>
+          <a:bodyPr wrap="square" lIns="27432" rIns="27432" tIns="18288" bIns="18288" anchor="ctr">
+            <a:spAutoFit/>
+          </a:bodyPr>
+          <a:lstStyle/>
+          <a:p>
+            <a:pPr algn="ctr"/>
+            <a:r>
+              <a:rPr sz="1050" b="1" i="1">
+                <a:solidFill>
+                  <a:srgbClr val="3D8B3D"/>
+                </a:solidFill>
+                <a:latin typeface="Calibri"/>
+              </a:rPr>
+              <a:t>Yes</a:t>
+            </a:r>
+          </a:p>
+        </p:txBody>
+      </p:sp>
+      <p:sp>
+        <p:nvSpPr>
+          <p:cNvPr id="31" name="TextBox 30"/>
+          <p:cNvSpPr txBox="1"/>
+          <p:nvPr/>
+        </p:nvSpPr>
+        <p:spPr>
+          <a:xfrm>
+            <a:off x="2075688" y="3977639"/>
+            <a:ext cx="457200" cy="201168"/>
+          </a:xfrm>
+          <a:prstGeom prst="rect">
+            <a:avLst/>
+          </a:prstGeom>
+          <a:noFill/>
+        </p:spPr>
+        <p:txBody>
+          <a:bodyPr wrap="square" lIns="27432" rIns="27432" tIns="18288" bIns="18288" anchor="ctr">
+            <a:spAutoFit/>
+          </a:bodyPr>
+          <a:lstStyle/>
+          <a:p>
+            <a:pPr algn="ctr"/>
+            <a:r>
+              <a:rPr sz="1050" b="1" i="1">
+                <a:solidFill>
+                  <a:srgbClr val="B0524C"/>
+                </a:solidFill>
+                <a:latin typeface="Calibri"/>
+              </a:rPr>
+              <a:t>No</a:t>
+            </a:r>
+          </a:p>
+        </p:txBody>
+      </p:sp>
+      <p:sp>
+        <p:nvSpPr>
+          <p:cNvPr id="32" name="TextBox 31"/>
+          <p:cNvSpPr txBox="1"/>
+          <p:nvPr/>
+        </p:nvSpPr>
+        <p:spPr>
+          <a:xfrm>
+            <a:off x="7982712" y="3611879"/>
+            <a:ext cx="640080" cy="201168"/>
+          </a:xfrm>
+          <a:prstGeom prst="rect">
+            <a:avLst/>
+          </a:prstGeom>
+          <a:noFill/>
+        </p:spPr>
+        <p:txBody>
+          <a:bodyPr wrap="square" lIns="27432" rIns="27432" tIns="18288" bIns="18288" anchor="ctr">
+            <a:spAutoFit/>
+          </a:bodyPr>
+          <a:lstStyle/>
+          <a:p>
+            <a:pPr algn="ctr"/>
+            <a:r>
+              <a:rPr sz="1050" b="1" i="1">
+                <a:solidFill>
+                  <a:srgbClr val="3D8B3D"/>
+                </a:solidFill>
+                <a:latin typeface="Calibri"/>
+              </a:rPr>
+              <a:t>Yes</a:t>
+            </a:r>
+          </a:p>
+        </p:txBody>
+      </p:sp>
+      <p:sp>
+        <p:nvSpPr>
+          <p:cNvPr id="33" name="TextBox 32"/>
+          <p:cNvSpPr txBox="1"/>
+          <p:nvPr/>
+        </p:nvSpPr>
+        <p:spPr>
+          <a:xfrm>
+            <a:off x="7013448" y="3977639"/>
+            <a:ext cx="457200" cy="201168"/>
+          </a:xfrm>
+          <a:prstGeom prst="rect">
+            <a:avLst/>
+          </a:prstGeom>
+          <a:noFill/>
+        </p:spPr>
+        <p:txBody>
+          <a:bodyPr wrap="square" lIns="27432" rIns="27432" tIns="18288" bIns="18288" anchor="ctr">
+            <a:spAutoFit/>
+          </a:bodyPr>
+          <a:lstStyle/>
+          <a:p>
+            <a:pPr algn="ctr"/>
+            <a:r>
+              <a:rPr sz="1050" b="1" i="1">
+                <a:solidFill>
+                  <a:srgbClr val="B0524C"/>
+                </a:solidFill>
+                <a:latin typeface="Calibri"/>
+              </a:rPr>
+              <a:t>No</a:t>
+            </a:r>
+          </a:p>
+        </p:txBody>
+      </p:sp>
+      <p:sp>
+        <p:nvSpPr>
+          <p:cNvPr id="34" name="TextBox 33"/>
+          <p:cNvSpPr txBox="1"/>
+          <p:nvPr/>
+        </p:nvSpPr>
+        <p:spPr>
+          <a:xfrm>
+            <a:off x="2834639" y="7315199"/>
+            <a:ext cx="822960" cy="201168"/>
+          </a:xfrm>
+          <a:prstGeom prst="rect">
+            <a:avLst/>
+          </a:prstGeom>
+          <a:noFill/>
+        </p:spPr>
+        <p:txBody>
+          <a:bodyPr wrap="square" lIns="27432" rIns="27432" tIns="18288" bIns="18288" anchor="ctr">
+            <a:spAutoFit/>
+          </a:bodyPr>
+          <a:lstStyle/>
+          <a:p>
+            <a:pPr algn="ctr"/>
+            <a:r>
+              <a:rPr sz="1050" b="1" i="1">
+                <a:solidFill>
+                  <a:srgbClr val="3D8B3D"/>
+                </a:solidFill>
+                <a:latin typeface="Calibri"/>
+              </a:rPr>
+              <a:t>Positive</a:t>
+            </a:r>
+          </a:p>
+        </p:txBody>
+      </p:sp>
+      <p:sp>
+        <p:nvSpPr>
+          <p:cNvPr id="35" name="TextBox 34"/>
+          <p:cNvSpPr txBox="1"/>
+          <p:nvPr/>
+        </p:nvSpPr>
+        <p:spPr>
+          <a:xfrm>
+            <a:off x="5486400" y="7315199"/>
+            <a:ext cx="822960" cy="201168"/>
+          </a:xfrm>
+          <a:prstGeom prst="rect">
+            <a:avLst/>
+          </a:prstGeom>
+          <a:noFill/>
+        </p:spPr>
+        <p:txBody>
+          <a:bodyPr wrap="square" lIns="27432" rIns="27432" tIns="18288" bIns="18288" anchor="ctr">
+            <a:spAutoFit/>
+          </a:bodyPr>
+          <a:lstStyle/>
+          <a:p>
+            <a:pPr algn="ctr"/>
+            <a:r>
+              <a:rPr sz="1050" b="1" i="1">
+                <a:solidFill>
+                  <a:srgbClr val="B0524C"/>
+                </a:solidFill>
+                <a:latin typeface="Calibri"/>
+              </a:rPr>
+              <a:t>Negative</a:t>
+            </a:r>
+          </a:p>
+        </p:txBody>
+      </p:sp>
+      <p:sp>
+        <p:nvSpPr>
+          <p:cNvPr id="36" name="Rounded Rectangle 35"/>
           <p:cNvSpPr/>
           <p:nvPr/>
         </p:nvSpPr>
@@ -4772,7 +4661,7 @@
       </p:sp>
       <p:sp>
         <p:nvSpPr>
-          <p:cNvPr id="41" name="TextBox 40"/>
+          <p:cNvPr id="37" name="TextBox 36"/>
           <p:cNvSpPr txBox="1"/>
           <p:nvPr/>
         </p:nvSpPr>
@@ -4787,7 +4676,7 @@
           <a:noFill/>
         </p:spPr>
         <p:txBody>
-          <a:bodyPr wrap="square" lIns="18288" rIns="18288" tIns="18288" bIns="18288" anchor="ctr">
+          <a:bodyPr wrap="square" lIns="27432" rIns="27432" tIns="18288" bIns="18288" anchor="ctr">
             <a:spAutoFit/>
           </a:bodyPr>
           <a:lstStyle/>
@@ -4807,7 +4696,7 @@
       </p:sp>
       <p:cxnSp>
         <p:nvCxnSpPr>
-          <p:cNvPr id="42" name="Connector 41"/>
+          <p:cNvPr id="38" name="Connector 37"/>
           <p:cNvCxnSpPr/>
           <p:nvPr/>
         </p:nvCxnSpPr>
@@ -4842,7 +4731,7 @@
       </p:cxnSp>
       <p:sp>
         <p:nvSpPr>
-          <p:cNvPr id="43" name="TextBox 42"/>
+          <p:cNvPr id="39" name="TextBox 38"/>
           <p:cNvSpPr txBox="1"/>
           <p:nvPr/>
         </p:nvSpPr>
@@ -4873,7 +4762,7 @@
               <a:t>¹  Reversible — </a:t>
             </a:r>
             <a:r>
-              <a:rPr sz="1050">
+              <a:rPr sz="1050" b="0">
                 <a:solidFill>
                   <a:srgbClr val="1A1A1A"/>
                 </a:solidFill>
@@ -4886,7 +4775,7 @@
       </p:sp>
       <p:sp>
         <p:nvSpPr>
-          <p:cNvPr id="44" name="TextBox 43"/>
+          <p:cNvPr id="40" name="TextBox 39"/>
           <p:cNvSpPr txBox="1"/>
           <p:nvPr/>
         </p:nvSpPr>
@@ -4917,7 +4806,7 @@
               <a:t>²  Important — </a:t>
             </a:r>
             <a:r>
-              <a:rPr sz="1050">
+              <a:rPr sz="1050" b="0">
                 <a:solidFill>
                   <a:srgbClr val="1A1A1A"/>
                 </a:solidFill>
@@ -4930,7 +4819,7 @@
       </p:sp>
       <p:sp>
         <p:nvSpPr>
-          <p:cNvPr id="45" name="TextBox 44"/>
+          <p:cNvPr id="41" name="TextBox 40"/>
           <p:cNvSpPr txBox="1"/>
           <p:nvPr/>
         </p:nvSpPr>
@@ -4961,7 +4850,7 @@
               <a:t>³  Indirect tests (preferred) — </a:t>
             </a:r>
             <a:r>
-              <a:rPr sz="1050">
+              <a:rPr sz="1050" b="0">
                 <a:solidFill>
                   <a:srgbClr val="1A1A1A"/>
                 </a:solidFill>
@@ -4974,7 +4863,7 @@
       </p:sp>
       <p:sp>
         <p:nvSpPr>
-          <p:cNvPr id="46" name="TextBox 45"/>
+          <p:cNvPr id="42" name="TextBox 41"/>
           <p:cNvSpPr txBox="1"/>
           <p:nvPr/>
         </p:nvSpPr>
@@ -5005,7 +4894,7 @@
               <a:t>⁴  Positive bronchoprovocation — </a:t>
             </a:r>
             <a:r>
-              <a:rPr sz="1050">
+              <a:rPr sz="1050" b="0">
                 <a:solidFill>
                   <a:srgbClr val="1A1A1A"/>
                 </a:solidFill>
@@ -5018,7 +4907,7 @@
       </p:sp>
       <p:sp>
         <p:nvSpPr>
-          <p:cNvPr id="47" name="TextBox 46"/>
+          <p:cNvPr id="43" name="TextBox 42"/>
           <p:cNvSpPr txBox="1"/>
           <p:nvPr/>
         </p:nvSpPr>
@@ -5033,7 +4922,7 @@
           <a:noFill/>
         </p:spPr>
         <p:txBody>
-          <a:bodyPr wrap="square" lIns="18288" rIns="18288" tIns="18288" bIns="18288" anchor="ctr">
+          <a:bodyPr wrap="square" lIns="27432" rIns="27432" tIns="18288" bIns="18288" anchor="ctr">
             <a:spAutoFit/>
           </a:bodyPr>
           <a:lstStyle/>

</xml_diff>